<commit_message>
docs(website): chaos-engineering coverage + diagrams for chaos, LLM, verify responses
Expand the home page What-is-MockServer section with a dedicated chaos
engineering and resilience subsection (fault types, HTTP/gRPC/TCP scope,
scheduled experiments with auto-halt, Kubernetes/service-mesh chaos), and
add four new house-style flow diagrams:

- chaos / fault-injection action
- LLM response mocking action
- response verification (proxy)
- LLM proxy -> cost-optimisation brief

The diagrams are added as four new additional slides in
MockServerScenarios.pptx (existing slides untouched) and rendered to PNG
in the existing diagram style (dashed expectation boxes, shadowed action
boxes, arrowed connectors).
</commit_message>
<xml_diff>
--- a/jekyll-www.mock-server.com/images/MockServerScenarios.pptx
+++ b/jekyll-www.mock-server.com/images/MockServerScenarios.pptx
@@ -19,6 +19,10 @@
     <p:sldId id="259" r:id="rId10"/>
     <p:sldId id="269" r:id="rId11"/>
     <p:sldId id="272" r:id="rId12"/>
+    <p:sldId id="273" r:id="rId18"/>
+    <p:sldId id="274" r:id="rId19"/>
+    <p:sldId id="275" r:id="rId20"/>
+    <p:sldId id="276" r:id="rId21"/>
   </p:sldIdLst>
   <p:sldSz cx="21283613" cy="7099300"/>
   <p:notesSz cx="6858000" cy="9144000"/>
@@ -11838,6 +11842,2271 @@
 </p:sld>
 </file>
 
+<file path=ppt/slides/slide12.xml><?xml version="1.0" encoding="utf-8"?>
+<p:sld xmlns:a="http://schemas.openxmlformats.org/drawingml/2006/main" xmlns:p="http://schemas.openxmlformats.org/presentationml/2006/main" xmlns:r="http://schemas.openxmlformats.org/officeDocument/2006/relationships">
+  <p:cSld>
+    <p:spTree>
+      <p:nvGrpSpPr>
+        <p:cNvPr id="1" name=""/>
+        <p:cNvGrpSpPr/>
+        <p:nvPr/>
+      </p:nvGrpSpPr>
+      <p:grpSpPr/>
+      <p:cxnSp>
+        <p:nvCxnSpPr>
+          <p:cNvPr id="17" name="Straight Arrow Connector 16"/>
+          <p:cNvCxnSpPr/>
+          <p:nvPr/>
+        </p:nvCxnSpPr>
+        <p:spPr>
+          <a:xfrm flipV="1">
+            <a:off x="6606318" y="3568479"/>
+            <a:ext cx="1260401" cy="1888"/>
+          </a:xfrm>
+          <a:prstGeom prst="straightConnector1">
+            <a:avLst/>
+          </a:prstGeom>
+          <a:ln>
+            <a:tailEnd type="arrow"/>
+          </a:ln>
+        </p:spPr>
+        <p:style>
+          <a:lnRef idx="2">
+            <a:schemeClr val="accent1"/>
+          </a:lnRef>
+          <a:fillRef idx="0">
+            <a:schemeClr val="accent1"/>
+          </a:fillRef>
+          <a:effectRef idx="1">
+            <a:schemeClr val="accent1"/>
+          </a:effectRef>
+          <a:fontRef idx="minor">
+            <a:schemeClr val="tx1"/>
+          </a:fontRef>
+        </p:style>
+      </p:cxnSp>
+      <p:sp>
+        <p:nvSpPr>
+          <p:cNvPr id="18" name="TextBox 17"/>
+          <p:cNvSpPr txBox="1"/>
+          <p:nvPr/>
+        </p:nvSpPr>
+        <p:spPr>
+          <a:xfrm>
+            <a:off x="6511199" y="3291482"/>
+            <a:ext cx="1553402" cy="276999"/>
+          </a:xfrm>
+          <a:prstGeom prst="rect">
+            <a:avLst/>
+          </a:prstGeom>
+          <a:noFill/>
+        </p:spPr>
+        <p:txBody>
+          <a:bodyPr wrap="square" rtlCol="0">
+            <a:spAutoFit/>
+          </a:bodyPr>
+          <a:lstStyle/>
+          <a:p>
+            <a:r>
+              <a:rPr lang="en-US" sz="1200" dirty="0"/>
+              <a:t>1. Receive Request</a:t>
+            </a:r>
+          </a:p>
+        </p:txBody>
+      </p:sp>
+      <p:sp>
+        <p:nvSpPr>
+          <p:cNvPr id="67" name="TextBox 66"/>
+          <p:cNvSpPr txBox="1"/>
+          <p:nvPr/>
+        </p:nvSpPr>
+        <p:spPr>
+          <a:xfrm>
+            <a:off x="6519098" y="4323714"/>
+            <a:ext cx="1921769" cy="276999"/>
+          </a:xfrm>
+          <a:prstGeom prst="rect">
+            <a:avLst/>
+          </a:prstGeom>
+          <a:noFill/>
+        </p:spPr>
+        <p:txBody>
+          <a:bodyPr wrap="square" rtlCol="0">
+            <a:spAutoFit/>
+          </a:bodyPr>
+          <a:lstStyle/>
+          <a:p>
+            <a:r>
+              <a:rPr lang="en-US" sz="1200" dirty="0"/>
+              <a:t>3. Inject Fault</a:t>
+            </a:r>
+          </a:p>
+        </p:txBody>
+      </p:sp>
+      <p:grpSp>
+        <p:nvGrpSpPr>
+          <p:cNvPr id="2" name="Group 1"/>
+          <p:cNvGrpSpPr/>
+          <p:nvPr/>
+        </p:nvGrpSpPr>
+        <p:grpSpPr>
+          <a:xfrm>
+            <a:off x="7973480" y="2948459"/>
+            <a:ext cx="3997396" cy="2867691"/>
+            <a:chOff x="1903674" y="2827807"/>
+            <a:chExt cx="3866269" cy="2867691"/>
+          </a:xfrm>
+        </p:grpSpPr>
+        <p:sp>
+          <p:nvSpPr>
+            <p:cNvPr id="22" name="Rounded Rectangle 21"/>
+            <p:cNvSpPr/>
+            <p:nvPr/>
+          </p:nvSpPr>
+          <p:spPr>
+            <a:xfrm>
+              <a:off x="2208474" y="3132607"/>
+              <a:ext cx="3561469" cy="2562891"/>
+            </a:xfrm>
+            <a:prstGeom prst="roundRect">
+              <a:avLst/>
+            </a:prstGeom>
+            <a:solidFill>
+              <a:schemeClr val="bg1"/>
+            </a:solidFill>
+            <a:ln w="19050" cmpd="sng">
+              <a:solidFill>
+                <a:schemeClr val="tx1"/>
+              </a:solidFill>
+              <a:prstDash val="dash"/>
+            </a:ln>
+          </p:spPr>
+          <p:style>
+            <a:lnRef idx="1">
+              <a:schemeClr val="accent1"/>
+            </a:lnRef>
+            <a:fillRef idx="3">
+              <a:schemeClr val="accent1"/>
+            </a:fillRef>
+            <a:effectRef idx="2">
+              <a:schemeClr val="accent1"/>
+            </a:effectRef>
+            <a:fontRef idx="minor">
+              <a:schemeClr val="lt1"/>
+            </a:fontRef>
+          </p:style>
+          <p:txBody>
+            <a:bodyPr rtlCol="0" anchor="b" anchorCtr="0"/>
+            <a:lstStyle/>
+            <a:p>
+              <a:pPr algn="ctr"/>
+              <a:r>
+                <a:rPr lang="en-US" sz="1400" dirty="0">
+                  <a:solidFill>
+                    <a:schemeClr val="tx1"/>
+                  </a:solidFill>
+                  <a:latin typeface="Helvetica"/>
+                  <a:cs typeface="Helvetica"/>
+                </a:rPr>
+                <a:t>Expectation</a:t>
+              </a:r>
+            </a:p>
+          </p:txBody>
+        </p:sp>
+        <p:sp>
+          <p:nvSpPr>
+            <p:cNvPr id="21" name="Rounded Rectangle 20"/>
+            <p:cNvSpPr/>
+            <p:nvPr/>
+          </p:nvSpPr>
+          <p:spPr>
+            <a:xfrm>
+              <a:off x="2056074" y="2980207"/>
+              <a:ext cx="3561469" cy="2562891"/>
+            </a:xfrm>
+            <a:prstGeom prst="roundRect">
+              <a:avLst/>
+            </a:prstGeom>
+            <a:solidFill>
+              <a:schemeClr val="bg1"/>
+            </a:solidFill>
+            <a:ln w="19050" cmpd="sng">
+              <a:solidFill>
+                <a:schemeClr val="tx1"/>
+              </a:solidFill>
+              <a:prstDash val="dash"/>
+            </a:ln>
+          </p:spPr>
+          <p:style>
+            <a:lnRef idx="1">
+              <a:schemeClr val="accent1"/>
+            </a:lnRef>
+            <a:fillRef idx="3">
+              <a:schemeClr val="accent1"/>
+            </a:fillRef>
+            <a:effectRef idx="2">
+              <a:schemeClr val="accent1"/>
+            </a:effectRef>
+            <a:fontRef idx="minor">
+              <a:schemeClr val="lt1"/>
+            </a:fontRef>
+          </p:style>
+          <p:txBody>
+            <a:bodyPr rtlCol="0" anchor="b" anchorCtr="0"/>
+            <a:lstStyle/>
+            <a:p>
+              <a:pPr algn="ctr"/>
+              <a:r>
+                <a:rPr lang="en-US" sz="1400" dirty="0">
+                  <a:solidFill>
+                    <a:schemeClr val="tx1"/>
+                  </a:solidFill>
+                  <a:latin typeface="Helvetica"/>
+                  <a:cs typeface="Helvetica"/>
+                </a:rPr>
+                <a:t>Expectation</a:t>
+              </a:r>
+            </a:p>
+          </p:txBody>
+        </p:sp>
+        <p:sp>
+          <p:nvSpPr>
+            <p:cNvPr id="73" name="Rounded Rectangle 72"/>
+            <p:cNvSpPr/>
+            <p:nvPr/>
+          </p:nvSpPr>
+          <p:spPr>
+            <a:xfrm>
+              <a:off x="1903674" y="2827807"/>
+              <a:ext cx="3561469" cy="2562891"/>
+            </a:xfrm>
+            <a:prstGeom prst="roundRect">
+              <a:avLst/>
+            </a:prstGeom>
+            <a:solidFill>
+              <a:schemeClr val="bg1"/>
+            </a:solidFill>
+            <a:ln w="19050" cmpd="sng">
+              <a:solidFill>
+                <a:schemeClr val="tx1"/>
+              </a:solidFill>
+              <a:prstDash val="dash"/>
+            </a:ln>
+          </p:spPr>
+          <p:style>
+            <a:lnRef idx="1">
+              <a:schemeClr val="accent1"/>
+            </a:lnRef>
+            <a:fillRef idx="3">
+              <a:schemeClr val="accent1"/>
+            </a:fillRef>
+            <a:effectRef idx="2">
+              <a:schemeClr val="accent1"/>
+            </a:effectRef>
+            <a:fontRef idx="minor">
+              <a:schemeClr val="lt1"/>
+            </a:fontRef>
+          </p:style>
+          <p:txBody>
+            <a:bodyPr rtlCol="0" anchor="b" anchorCtr="0"/>
+            <a:lstStyle/>
+            <a:p>
+              <a:pPr algn="ctr"/>
+              <a:r>
+                <a:rPr lang="en-US" sz="1400" dirty="0">
+                  <a:solidFill>
+                    <a:schemeClr val="tx1"/>
+                  </a:solidFill>
+                  <a:latin typeface="Helvetica"/>
+                  <a:cs typeface="Helvetica"/>
+                </a:rPr>
+                <a:t>Expectation</a:t>
+              </a:r>
+            </a:p>
+          </p:txBody>
+        </p:sp>
+      </p:grpSp>
+      <p:sp>
+        <p:nvSpPr>
+          <p:cNvPr id="75" name="Rectangle 74"/>
+          <p:cNvSpPr/>
+          <p:nvPr/>
+        </p:nvSpPr>
+        <p:spPr>
+          <a:xfrm>
+            <a:off x="9469602" y="3238315"/>
+            <a:ext cx="940561" cy="664100"/>
+          </a:xfrm>
+          <a:prstGeom prst="rect">
+            <a:avLst/>
+          </a:prstGeom>
+          <a:solidFill>
+            <a:schemeClr val="bg1"/>
+          </a:solidFill>
+          <a:ln w="19050" cmpd="sng">
+            <a:solidFill>
+              <a:schemeClr val="tx1"/>
+            </a:solidFill>
+          </a:ln>
+        </p:spPr>
+        <p:style>
+          <a:lnRef idx="1">
+            <a:schemeClr val="accent1"/>
+          </a:lnRef>
+          <a:fillRef idx="3">
+            <a:schemeClr val="accent1"/>
+          </a:fillRef>
+          <a:effectRef idx="2">
+            <a:schemeClr val="accent1"/>
+          </a:effectRef>
+          <a:fontRef idx="minor">
+            <a:schemeClr val="lt1"/>
+          </a:fontRef>
+        </p:style>
+        <p:txBody>
+          <a:bodyPr lIns="91436" tIns="45718" rIns="91436" bIns="45718" rtlCol="0" anchor="ctr" anchorCtr="0"/>
+          <a:lstStyle/>
+          <a:p>
+            <a:pPr algn="ctr"/>
+            <a:r>
+              <a:rPr lang="en-US" sz="900" dirty="0">
+                <a:solidFill>
+                  <a:schemeClr val="tx1"/>
+                </a:solidFill>
+                <a:latin typeface="Helvetica"/>
+                <a:cs typeface="Helvetica"/>
+              </a:rPr>
+              <a:t>Request</a:t>
+            </a:r>
+          </a:p>
+          <a:p>
+            <a:pPr algn="ctr"/>
+            <a:r>
+              <a:rPr lang="en-US" sz="900" dirty="0">
+                <a:solidFill>
+                  <a:schemeClr val="tx1"/>
+                </a:solidFill>
+                <a:latin typeface="Helvetica"/>
+                <a:cs typeface="Helvetica"/>
+              </a:rPr>
+              <a:t>Matcher</a:t>
+            </a:r>
+          </a:p>
+        </p:txBody>
+      </p:sp>
+      <p:cxnSp>
+        <p:nvCxnSpPr>
+          <p:cNvPr id="88" name="Straight Arrow Connector 87"/>
+          <p:cNvCxnSpPr/>
+          <p:nvPr/>
+        </p:nvCxnSpPr>
+        <p:spPr>
+          <a:xfrm flipH="1" flipV="1">
+            <a:off x="6606316" y="4594953"/>
+            <a:ext cx="3567666" cy="2512"/>
+          </a:xfrm>
+          <a:prstGeom prst="straightConnector1">
+            <a:avLst/>
+          </a:prstGeom>
+          <a:ln>
+            <a:solidFill>
+              <a:srgbClr val="C00000"/>
+            </a:solidFill>
+            <a:tailEnd type="triangle"/>
+          </a:ln>
+        </p:spPr>
+        <p:style>
+          <a:lnRef idx="2">
+            <a:schemeClr val="accent1"/>
+          </a:lnRef>
+          <a:fillRef idx="0">
+            <a:schemeClr val="accent1"/>
+          </a:fillRef>
+          <a:effectRef idx="1">
+            <a:schemeClr val="accent1"/>
+          </a:effectRef>
+          <a:fontRef idx="minor">
+            <a:schemeClr val="tx1"/>
+          </a:fontRef>
+        </p:style>
+      </p:cxnSp>
+      <p:sp>
+        <p:nvSpPr>
+          <p:cNvPr id="92" name="TextBox 91"/>
+          <p:cNvSpPr txBox="1"/>
+          <p:nvPr/>
+        </p:nvSpPr>
+        <p:spPr>
+          <a:xfrm>
+            <a:off x="8083349" y="3293474"/>
+            <a:ext cx="1553402" cy="276999"/>
+          </a:xfrm>
+          <a:prstGeom prst="rect">
+            <a:avLst/>
+          </a:prstGeom>
+          <a:noFill/>
+          <a:effectLst>
+            <a:softEdge rad="12700"/>
+          </a:effectLst>
+        </p:spPr>
+        <p:txBody>
+          <a:bodyPr wrap="square" rtlCol="0">
+            <a:spAutoFit/>
+          </a:bodyPr>
+          <a:lstStyle/>
+          <a:p>
+            <a:r>
+              <a:rPr lang="en-US" sz="1200" dirty="0"/>
+              <a:t>2. Match Request</a:t>
+            </a:r>
+          </a:p>
+        </p:txBody>
+      </p:sp>
+      <p:cxnSp>
+        <p:nvCxnSpPr>
+          <p:cNvPr id="101" name="Straight Arrow Connector 100"/>
+          <p:cNvCxnSpPr/>
+          <p:nvPr/>
+        </p:nvCxnSpPr>
+        <p:spPr>
+          <a:xfrm>
+            <a:off x="8178829" y="3570365"/>
+            <a:ext cx="1176446" cy="0"/>
+          </a:xfrm>
+          <a:prstGeom prst="straightConnector1">
+            <a:avLst/>
+          </a:prstGeom>
+          <a:ln>
+            <a:tailEnd type="triangle"/>
+          </a:ln>
+        </p:spPr>
+        <p:style>
+          <a:lnRef idx="2">
+            <a:schemeClr val="accent1"/>
+          </a:lnRef>
+          <a:fillRef idx="0">
+            <a:schemeClr val="accent1"/>
+          </a:fillRef>
+          <a:effectRef idx="1">
+            <a:schemeClr val="accent1"/>
+          </a:effectRef>
+          <a:fontRef idx="minor">
+            <a:schemeClr val="tx1"/>
+          </a:fontRef>
+        </p:style>
+      </p:cxnSp>
+      <p:sp>
+        <p:nvSpPr>
+          <p:cNvPr id="19" name="Rectangle 18"/>
+          <p:cNvSpPr/>
+          <p:nvPr/>
+        </p:nvSpPr>
+        <p:spPr>
+          <a:xfrm>
+            <a:off x="10305924" y="4278588"/>
+            <a:ext cx="940561" cy="664100"/>
+          </a:xfrm>
+          <a:prstGeom prst="rect">
+            <a:avLst/>
+          </a:prstGeom>
+          <a:solidFill>
+            <a:schemeClr val="bg1"/>
+          </a:solidFill>
+          <a:ln w="19050" cmpd="sng">
+            <a:solidFill>
+              <a:schemeClr val="tx1"/>
+            </a:solidFill>
+          </a:ln>
+        </p:spPr>
+        <p:style>
+          <a:lnRef idx="1">
+            <a:schemeClr val="accent1"/>
+          </a:lnRef>
+          <a:fillRef idx="3">
+            <a:schemeClr val="accent1"/>
+          </a:fillRef>
+          <a:effectRef idx="2">
+            <a:schemeClr val="accent1"/>
+          </a:effectRef>
+          <a:fontRef idx="minor">
+            <a:schemeClr val="lt1"/>
+          </a:fontRef>
+        </p:style>
+        <p:txBody>
+          <a:bodyPr lIns="91436" tIns="45718" rIns="91436" bIns="45718" rtlCol="0" anchor="ctr" anchorCtr="0"/>
+          <a:lstStyle/>
+          <a:p>
+            <a:pPr algn="ctr"/>
+            <a:r>
+              <a:rPr lang="en-US" sz="900" dirty="0">
+                <a:solidFill>
+                  <a:schemeClr val="tx1"/>
+                </a:solidFill>
+                <a:latin typeface="Helvetica"/>
+                <a:cs typeface="Helvetica"/>
+              </a:rPr>
+              <a:t>Chaos</a:t>
+            </a:r>
+          </a:p>
+          <a:p>
+            <a:pPr algn="ctr"/>
+            <a:r>
+              <a:rPr lang="en-US" sz="900" dirty="0">
+                <a:solidFill>
+                  <a:schemeClr val="tx1"/>
+                </a:solidFill>
+                <a:latin typeface="Helvetica"/>
+                <a:cs typeface="Helvetica"/>
+              </a:rPr>
+              <a:t>Action</a:t>
+            </a:r>
+          </a:p>
+        </p:txBody>
+      </p:sp>
+      <p:cxnSp>
+        <p:nvCxnSpPr>
+          <p:cNvPr id="20" name="Elbow Connector 19"/>
+          <p:cNvCxnSpPr/>
+          <p:nvPr/>
+        </p:nvCxnSpPr>
+        <p:spPr>
+          <a:xfrm>
+            <a:off x="10410161" y="3570367"/>
+            <a:ext cx="366042" cy="708223"/>
+          </a:xfrm>
+          <a:prstGeom prst="bentConnector2">
+            <a:avLst/>
+          </a:prstGeom>
+          <a:ln>
+            <a:tailEnd type="triangle"/>
+          </a:ln>
+        </p:spPr>
+        <p:style>
+          <a:lnRef idx="2">
+            <a:schemeClr val="accent1"/>
+          </a:lnRef>
+          <a:fillRef idx="0">
+            <a:schemeClr val="accent1"/>
+          </a:fillRef>
+          <a:effectRef idx="1">
+            <a:schemeClr val="accent1"/>
+          </a:effectRef>
+          <a:fontRef idx="minor">
+            <a:schemeClr val="tx1"/>
+          </a:fontRef>
+        </p:style>
+      </p:cxnSp>
+    </p:spTree>
+  </p:cSld>
+  <p:clrMapOvr>
+    <a:masterClrMapping/>
+  </p:clrMapOvr>
+</p:sld>
+</file>
+
+<file path=ppt/slides/slide13.xml><?xml version="1.0" encoding="utf-8"?>
+<p:sld xmlns:a="http://schemas.openxmlformats.org/drawingml/2006/main" xmlns:p="http://schemas.openxmlformats.org/presentationml/2006/main" xmlns:r="http://schemas.openxmlformats.org/officeDocument/2006/relationships">
+  <p:cSld>
+    <p:spTree>
+      <p:nvGrpSpPr>
+        <p:cNvPr id="1" name=""/>
+        <p:cNvGrpSpPr/>
+        <p:nvPr/>
+      </p:nvGrpSpPr>
+      <p:grpSpPr/>
+      <p:grpSp>
+        <p:nvGrpSpPr>
+          <p:cNvPr id="23" name="Group 22"/>
+          <p:cNvGrpSpPr/>
+          <p:nvPr/>
+        </p:nvGrpSpPr>
+        <p:grpSpPr>
+          <a:xfrm>
+            <a:off x="7973480" y="2948459"/>
+            <a:ext cx="3997396" cy="2867691"/>
+            <a:chOff x="1903674" y="2827807"/>
+            <a:chExt cx="3866269" cy="2867691"/>
+          </a:xfrm>
+        </p:grpSpPr>
+        <p:sp>
+          <p:nvSpPr>
+            <p:cNvPr id="24" name="Rounded Rectangle 23"/>
+            <p:cNvSpPr/>
+            <p:nvPr/>
+          </p:nvSpPr>
+          <p:spPr>
+            <a:xfrm>
+              <a:off x="2208474" y="3132607"/>
+              <a:ext cx="3561469" cy="2562891"/>
+            </a:xfrm>
+            <a:prstGeom prst="roundRect">
+              <a:avLst/>
+            </a:prstGeom>
+            <a:solidFill>
+              <a:schemeClr val="bg1"/>
+            </a:solidFill>
+            <a:ln w="19050" cmpd="sng">
+              <a:solidFill>
+                <a:schemeClr val="tx1"/>
+              </a:solidFill>
+              <a:prstDash val="dash"/>
+            </a:ln>
+          </p:spPr>
+          <p:style>
+            <a:lnRef idx="1">
+              <a:schemeClr val="accent4"/>
+            </a:lnRef>
+            <a:fillRef idx="3">
+              <a:schemeClr val="accent4"/>
+            </a:fillRef>
+            <a:effectRef idx="2">
+              <a:schemeClr val="accent4"/>
+            </a:effectRef>
+            <a:fontRef idx="minor">
+              <a:schemeClr val="lt1"/>
+            </a:fontRef>
+          </p:style>
+          <p:txBody>
+            <a:bodyPr rtlCol="0" anchor="b" anchorCtr="0"/>
+            <a:lstStyle/>
+            <a:p>
+              <a:pPr algn="ctr"/>
+              <a:r>
+                <a:rPr lang="en-US" sz="1400" dirty="0">
+                  <a:solidFill>
+                    <a:schemeClr val="tx1"/>
+                  </a:solidFill>
+                  <a:latin typeface="Helvetica"/>
+                  <a:cs typeface="Helvetica"/>
+                </a:rPr>
+                <a:t>Expectation</a:t>
+              </a:r>
+            </a:p>
+          </p:txBody>
+        </p:sp>
+        <p:sp>
+          <p:nvSpPr>
+            <p:cNvPr id="25" name="Rounded Rectangle 24"/>
+            <p:cNvSpPr/>
+            <p:nvPr/>
+          </p:nvSpPr>
+          <p:spPr>
+            <a:xfrm>
+              <a:off x="2056074" y="2980207"/>
+              <a:ext cx="3561469" cy="2562891"/>
+            </a:xfrm>
+            <a:prstGeom prst="roundRect">
+              <a:avLst/>
+            </a:prstGeom>
+            <a:solidFill>
+              <a:schemeClr val="bg1"/>
+            </a:solidFill>
+            <a:ln w="19050" cmpd="sng">
+              <a:solidFill>
+                <a:schemeClr val="tx1"/>
+              </a:solidFill>
+              <a:prstDash val="dash"/>
+            </a:ln>
+          </p:spPr>
+          <p:style>
+            <a:lnRef idx="1">
+              <a:schemeClr val="accent4"/>
+            </a:lnRef>
+            <a:fillRef idx="3">
+              <a:schemeClr val="accent4"/>
+            </a:fillRef>
+            <a:effectRef idx="2">
+              <a:schemeClr val="accent4"/>
+            </a:effectRef>
+            <a:fontRef idx="minor">
+              <a:schemeClr val="lt1"/>
+            </a:fontRef>
+          </p:style>
+          <p:txBody>
+            <a:bodyPr rtlCol="0" anchor="b" anchorCtr="0"/>
+            <a:lstStyle/>
+            <a:p>
+              <a:pPr algn="ctr"/>
+              <a:r>
+                <a:rPr lang="en-US" sz="1400" dirty="0">
+                  <a:solidFill>
+                    <a:schemeClr val="tx1"/>
+                  </a:solidFill>
+                  <a:latin typeface="Helvetica"/>
+                  <a:cs typeface="Helvetica"/>
+                </a:rPr>
+                <a:t>Expectation</a:t>
+              </a:r>
+            </a:p>
+          </p:txBody>
+        </p:sp>
+        <p:sp>
+          <p:nvSpPr>
+            <p:cNvPr id="26" name="Rounded Rectangle 25"/>
+            <p:cNvSpPr/>
+            <p:nvPr/>
+          </p:nvSpPr>
+          <p:spPr>
+            <a:xfrm>
+              <a:off x="1903674" y="2827807"/>
+              <a:ext cx="3561469" cy="2562891"/>
+            </a:xfrm>
+            <a:prstGeom prst="roundRect">
+              <a:avLst/>
+            </a:prstGeom>
+            <a:solidFill>
+              <a:schemeClr val="bg1"/>
+            </a:solidFill>
+            <a:ln w="19050" cmpd="sng">
+              <a:solidFill>
+                <a:schemeClr val="tx1"/>
+              </a:solidFill>
+              <a:prstDash val="dash"/>
+            </a:ln>
+          </p:spPr>
+          <p:style>
+            <a:lnRef idx="1">
+              <a:schemeClr val="accent4"/>
+            </a:lnRef>
+            <a:fillRef idx="3">
+              <a:schemeClr val="accent4"/>
+            </a:fillRef>
+            <a:effectRef idx="2">
+              <a:schemeClr val="accent4"/>
+            </a:effectRef>
+            <a:fontRef idx="minor">
+              <a:schemeClr val="lt1"/>
+            </a:fontRef>
+          </p:style>
+          <p:txBody>
+            <a:bodyPr rtlCol="0" anchor="b" anchorCtr="0"/>
+            <a:lstStyle/>
+            <a:p>
+              <a:pPr algn="ctr"/>
+              <a:r>
+                <a:rPr lang="en-US" sz="1400" dirty="0">
+                  <a:solidFill>
+                    <a:schemeClr val="tx1"/>
+                  </a:solidFill>
+                  <a:latin typeface="Helvetica"/>
+                  <a:cs typeface="Helvetica"/>
+                </a:rPr>
+                <a:t>Expectation</a:t>
+              </a:r>
+            </a:p>
+          </p:txBody>
+        </p:sp>
+      </p:grpSp>
+      <p:cxnSp>
+        <p:nvCxnSpPr>
+          <p:cNvPr id="17" name="Straight Arrow Connector 16"/>
+          <p:cNvCxnSpPr/>
+          <p:nvPr/>
+        </p:nvCxnSpPr>
+        <p:spPr>
+          <a:xfrm flipV="1">
+            <a:off x="6606318" y="3568479"/>
+            <a:ext cx="1260401" cy="1888"/>
+          </a:xfrm>
+          <a:prstGeom prst="straightConnector1">
+            <a:avLst/>
+          </a:prstGeom>
+          <a:ln>
+            <a:tailEnd type="arrow"/>
+          </a:ln>
+        </p:spPr>
+        <p:style>
+          <a:lnRef idx="2">
+            <a:schemeClr val="accent4"/>
+          </a:lnRef>
+          <a:fillRef idx="0">
+            <a:schemeClr val="accent4"/>
+          </a:fillRef>
+          <a:effectRef idx="1">
+            <a:schemeClr val="accent4"/>
+          </a:effectRef>
+          <a:fontRef idx="minor">
+            <a:schemeClr val="tx1"/>
+          </a:fontRef>
+        </p:style>
+      </p:cxnSp>
+      <p:sp>
+        <p:nvSpPr>
+          <p:cNvPr id="18" name="TextBox 17"/>
+          <p:cNvSpPr txBox="1"/>
+          <p:nvPr/>
+        </p:nvSpPr>
+        <p:spPr>
+          <a:xfrm>
+            <a:off x="6511199" y="3291482"/>
+            <a:ext cx="1553402" cy="276999"/>
+          </a:xfrm>
+          <a:prstGeom prst="rect">
+            <a:avLst/>
+          </a:prstGeom>
+          <a:noFill/>
+        </p:spPr>
+        <p:txBody>
+          <a:bodyPr wrap="square" rtlCol="0">
+            <a:spAutoFit/>
+          </a:bodyPr>
+          <a:lstStyle/>
+          <a:p>
+            <a:r>
+              <a:rPr lang="en-US" sz="1200" dirty="0"/>
+              <a:t>1. Receive Prompt</a:t>
+            </a:r>
+          </a:p>
+        </p:txBody>
+      </p:sp>
+      <p:sp>
+        <p:nvSpPr>
+          <p:cNvPr id="67" name="TextBox 66"/>
+          <p:cNvSpPr txBox="1"/>
+          <p:nvPr/>
+        </p:nvSpPr>
+        <p:spPr>
+          <a:xfrm>
+            <a:off x="6519097" y="4323714"/>
+            <a:ext cx="1553402" cy="276999"/>
+          </a:xfrm>
+          <a:prstGeom prst="rect">
+            <a:avLst/>
+          </a:prstGeom>
+          <a:noFill/>
+        </p:spPr>
+        <p:txBody>
+          <a:bodyPr wrap="square" rtlCol="0">
+            <a:spAutoFit/>
+          </a:bodyPr>
+          <a:lstStyle/>
+          <a:p>
+            <a:r>
+              <a:rPr lang="en-US" sz="1200" dirty="0"/>
+              <a:t>3. Stream Tokens</a:t>
+            </a:r>
+          </a:p>
+        </p:txBody>
+      </p:sp>
+      <p:sp>
+        <p:nvSpPr>
+          <p:cNvPr id="75" name="Rectangle 74"/>
+          <p:cNvSpPr/>
+          <p:nvPr/>
+        </p:nvSpPr>
+        <p:spPr>
+          <a:xfrm>
+            <a:off x="9469602" y="3238315"/>
+            <a:ext cx="940561" cy="664100"/>
+          </a:xfrm>
+          <a:prstGeom prst="rect">
+            <a:avLst/>
+          </a:prstGeom>
+          <a:solidFill>
+            <a:schemeClr val="bg1"/>
+          </a:solidFill>
+          <a:ln w="19050" cmpd="sng">
+            <a:solidFill>
+              <a:schemeClr val="tx1"/>
+            </a:solidFill>
+          </a:ln>
+        </p:spPr>
+        <p:style>
+          <a:lnRef idx="1">
+            <a:schemeClr val="accent4"/>
+          </a:lnRef>
+          <a:fillRef idx="3">
+            <a:schemeClr val="accent4"/>
+          </a:fillRef>
+          <a:effectRef idx="2">
+            <a:schemeClr val="accent4"/>
+          </a:effectRef>
+          <a:fontRef idx="minor">
+            <a:schemeClr val="lt1"/>
+          </a:fontRef>
+        </p:style>
+        <p:txBody>
+          <a:bodyPr lIns="91436" tIns="45718" rIns="91436" bIns="45718" rtlCol="0" anchor="ctr" anchorCtr="0"/>
+          <a:lstStyle/>
+          <a:p>
+            <a:pPr algn="ctr"/>
+            <a:r>
+              <a:rPr lang="en-US" sz="900" dirty="0">
+                <a:solidFill>
+                  <a:schemeClr val="tx1"/>
+                </a:solidFill>
+                <a:latin typeface="Helvetica"/>
+                <a:cs typeface="Helvetica"/>
+              </a:rPr>
+              <a:t>Request</a:t>
+            </a:r>
+          </a:p>
+          <a:p>
+            <a:pPr algn="ctr"/>
+            <a:r>
+              <a:rPr lang="en-US" sz="900" dirty="0">
+                <a:solidFill>
+                  <a:schemeClr val="tx1"/>
+                </a:solidFill>
+                <a:latin typeface="Helvetica"/>
+                <a:cs typeface="Helvetica"/>
+              </a:rPr>
+              <a:t>Matcher</a:t>
+            </a:r>
+          </a:p>
+        </p:txBody>
+      </p:sp>
+      <p:cxnSp>
+        <p:nvCxnSpPr>
+          <p:cNvPr id="88" name="Straight Arrow Connector 87"/>
+          <p:cNvCxnSpPr/>
+          <p:nvPr/>
+        </p:nvCxnSpPr>
+        <p:spPr>
+          <a:xfrm flipH="1" flipV="1">
+            <a:off x="6606316" y="4594953"/>
+            <a:ext cx="3567666" cy="2512"/>
+          </a:xfrm>
+          <a:prstGeom prst="straightConnector1">
+            <a:avLst/>
+          </a:prstGeom>
+          <a:ln>
+            <a:tailEnd type="triangle"/>
+          </a:ln>
+        </p:spPr>
+        <p:style>
+          <a:lnRef idx="2">
+            <a:schemeClr val="accent4"/>
+          </a:lnRef>
+          <a:fillRef idx="0">
+            <a:schemeClr val="accent4"/>
+          </a:fillRef>
+          <a:effectRef idx="1">
+            <a:schemeClr val="accent4"/>
+          </a:effectRef>
+          <a:fontRef idx="minor">
+            <a:schemeClr val="tx1"/>
+          </a:fontRef>
+        </p:style>
+      </p:cxnSp>
+      <p:sp>
+        <p:nvSpPr>
+          <p:cNvPr id="92" name="TextBox 91"/>
+          <p:cNvSpPr txBox="1"/>
+          <p:nvPr/>
+        </p:nvSpPr>
+        <p:spPr>
+          <a:xfrm>
+            <a:off x="8083349" y="3293474"/>
+            <a:ext cx="1553402" cy="276999"/>
+          </a:xfrm>
+          <a:prstGeom prst="rect">
+            <a:avLst/>
+          </a:prstGeom>
+          <a:noFill/>
+          <a:effectLst>
+            <a:softEdge rad="12700"/>
+          </a:effectLst>
+        </p:spPr>
+        <p:txBody>
+          <a:bodyPr wrap="square" rtlCol="0">
+            <a:spAutoFit/>
+          </a:bodyPr>
+          <a:lstStyle/>
+          <a:p>
+            <a:r>
+              <a:rPr lang="en-US" sz="1200" dirty="0"/>
+              <a:t>2. Match Request</a:t>
+            </a:r>
+          </a:p>
+        </p:txBody>
+      </p:sp>
+      <p:cxnSp>
+        <p:nvCxnSpPr>
+          <p:cNvPr id="101" name="Straight Arrow Connector 100"/>
+          <p:cNvCxnSpPr/>
+          <p:nvPr/>
+        </p:nvCxnSpPr>
+        <p:spPr>
+          <a:xfrm>
+            <a:off x="8178829" y="3570365"/>
+            <a:ext cx="1176446" cy="0"/>
+          </a:xfrm>
+          <a:prstGeom prst="straightConnector1">
+            <a:avLst/>
+          </a:prstGeom>
+          <a:ln>
+            <a:tailEnd type="triangle"/>
+          </a:ln>
+        </p:spPr>
+        <p:style>
+          <a:lnRef idx="2">
+            <a:schemeClr val="accent4"/>
+          </a:lnRef>
+          <a:fillRef idx="0">
+            <a:schemeClr val="accent4"/>
+          </a:fillRef>
+          <a:effectRef idx="1">
+            <a:schemeClr val="accent4"/>
+          </a:effectRef>
+          <a:fontRef idx="minor">
+            <a:schemeClr val="tx1"/>
+          </a:fontRef>
+        </p:style>
+      </p:cxnSp>
+      <p:sp>
+        <p:nvSpPr>
+          <p:cNvPr id="19" name="Rectangle 18"/>
+          <p:cNvSpPr/>
+          <p:nvPr/>
+        </p:nvSpPr>
+        <p:spPr>
+          <a:xfrm>
+            <a:off x="10305924" y="4278588"/>
+            <a:ext cx="940561" cy="664100"/>
+          </a:xfrm>
+          <a:prstGeom prst="rect">
+            <a:avLst/>
+          </a:prstGeom>
+          <a:solidFill>
+            <a:schemeClr val="bg1"/>
+          </a:solidFill>
+          <a:ln w="19050" cmpd="sng">
+            <a:solidFill>
+              <a:schemeClr val="tx1"/>
+            </a:solidFill>
+          </a:ln>
+        </p:spPr>
+        <p:style>
+          <a:lnRef idx="1">
+            <a:schemeClr val="accent4"/>
+          </a:lnRef>
+          <a:fillRef idx="3">
+            <a:schemeClr val="accent4"/>
+          </a:fillRef>
+          <a:effectRef idx="2">
+            <a:schemeClr val="accent4"/>
+          </a:effectRef>
+          <a:fontRef idx="minor">
+            <a:schemeClr val="lt1"/>
+          </a:fontRef>
+        </p:style>
+        <p:txBody>
+          <a:bodyPr lIns="91436" tIns="45718" rIns="91436" bIns="45718" rtlCol="0" anchor="ctr" anchorCtr="0"/>
+          <a:lstStyle/>
+          <a:p>
+            <a:pPr algn="ctr"/>
+            <a:r>
+              <a:rPr lang="en-US" sz="900" dirty="0">
+                <a:solidFill>
+                  <a:schemeClr val="tx1"/>
+                </a:solidFill>
+                <a:latin typeface="Helvetica"/>
+                <a:cs typeface="Helvetica"/>
+              </a:rPr>
+              <a:t>LLM</a:t>
+            </a:r>
+          </a:p>
+          <a:p>
+            <a:pPr algn="ctr"/>
+            <a:r>
+              <a:rPr lang="en-US" sz="900" dirty="0">
+                <a:solidFill>
+                  <a:schemeClr val="tx1"/>
+                </a:solidFill>
+                <a:latin typeface="Helvetica"/>
+                <a:cs typeface="Helvetica"/>
+              </a:rPr>
+              <a:t>Response</a:t>
+            </a:r>
+          </a:p>
+        </p:txBody>
+      </p:sp>
+      <p:cxnSp>
+        <p:nvCxnSpPr>
+          <p:cNvPr id="20" name="Elbow Connector 19"/>
+          <p:cNvCxnSpPr/>
+          <p:nvPr/>
+        </p:nvCxnSpPr>
+        <p:spPr>
+          <a:xfrm>
+            <a:off x="10410161" y="3570367"/>
+            <a:ext cx="366042" cy="708223"/>
+          </a:xfrm>
+          <a:prstGeom prst="bentConnector2">
+            <a:avLst/>
+          </a:prstGeom>
+          <a:ln>
+            <a:tailEnd type="triangle"/>
+          </a:ln>
+        </p:spPr>
+        <p:style>
+          <a:lnRef idx="2">
+            <a:schemeClr val="accent4"/>
+          </a:lnRef>
+          <a:fillRef idx="0">
+            <a:schemeClr val="accent4"/>
+          </a:fillRef>
+          <a:effectRef idx="1">
+            <a:schemeClr val="accent4"/>
+          </a:effectRef>
+          <a:fontRef idx="minor">
+            <a:schemeClr val="tx1"/>
+          </a:fontRef>
+        </p:style>
+      </p:cxnSp>
+    </p:spTree>
+  </p:cSld>
+  <p:clrMapOvr>
+    <a:masterClrMapping/>
+  </p:clrMapOvr>
+</p:sld>
+</file>
+
+<file path=ppt/slides/slide14.xml><?xml version="1.0" encoding="utf-8"?>
+<p:sld xmlns:a="http://schemas.openxmlformats.org/drawingml/2006/main" xmlns:p="http://schemas.openxmlformats.org/presentationml/2006/main" xmlns:r="http://schemas.openxmlformats.org/officeDocument/2006/relationships">
+  <p:cSld>
+    <p:spTree>
+      <p:nvGrpSpPr>
+        <p:cNvPr id="1" name=""/>
+        <p:cNvGrpSpPr/>
+        <p:nvPr/>
+      </p:nvGrpSpPr>
+      <p:grpSpPr/>
+      <p:cxnSp>
+        <p:nvCxnSpPr>
+          <p:cNvPr id="17" name="Straight Arrow Connector 16"/>
+          <p:cNvCxnSpPr/>
+          <p:nvPr/>
+        </p:nvCxnSpPr>
+        <p:spPr>
+          <a:xfrm flipV="1">
+            <a:off x="6606727" y="3566175"/>
+            <a:ext cx="1983406" cy="4192"/>
+          </a:xfrm>
+          <a:prstGeom prst="straightConnector1">
+            <a:avLst/>
+          </a:prstGeom>
+          <a:ln>
+            <a:tailEnd type="arrow"/>
+          </a:ln>
+        </p:spPr>
+        <p:style>
+          <a:lnRef idx="2">
+            <a:schemeClr val="accent1"/>
+          </a:lnRef>
+          <a:fillRef idx="0">
+            <a:schemeClr val="accent1"/>
+          </a:fillRef>
+          <a:effectRef idx="1">
+            <a:schemeClr val="accent1"/>
+          </a:effectRef>
+          <a:fontRef idx="minor">
+            <a:schemeClr val="tx1"/>
+          </a:fontRef>
+        </p:style>
+      </p:cxnSp>
+      <p:sp>
+        <p:nvSpPr>
+          <p:cNvPr id="18" name="TextBox 17"/>
+          <p:cNvSpPr txBox="1"/>
+          <p:nvPr/>
+        </p:nvSpPr>
+        <p:spPr>
+          <a:xfrm>
+            <a:off x="6521663" y="3291482"/>
+            <a:ext cx="2759008" cy="276999"/>
+          </a:xfrm>
+          <a:prstGeom prst="rect">
+            <a:avLst/>
+          </a:prstGeom>
+          <a:noFill/>
+        </p:spPr>
+        <p:txBody>
+          <a:bodyPr wrap="square" rtlCol="0">
+            <a:spAutoFit/>
+          </a:bodyPr>
+          <a:lstStyle/>
+          <a:p>
+            <a:r>
+              <a:rPr lang="en-US" sz="1200" dirty="0"/>
+              <a:t>3. Send Verification</a:t>
+            </a:r>
+          </a:p>
+        </p:txBody>
+      </p:sp>
+      <p:sp>
+        <p:nvSpPr>
+          <p:cNvPr id="67" name="TextBox 66"/>
+          <p:cNvSpPr txBox="1"/>
+          <p:nvPr/>
+        </p:nvSpPr>
+        <p:spPr>
+          <a:xfrm>
+            <a:off x="6521663" y="4121697"/>
+            <a:ext cx="1553402" cy="276999"/>
+          </a:xfrm>
+          <a:prstGeom prst="rect">
+            <a:avLst/>
+          </a:prstGeom>
+          <a:noFill/>
+        </p:spPr>
+        <p:txBody>
+          <a:bodyPr wrap="square" rtlCol="0">
+            <a:spAutoFit/>
+          </a:bodyPr>
+          <a:lstStyle/>
+          <a:p>
+            <a:r>
+              <a:rPr lang="en-US" sz="1200" dirty="0"/>
+              <a:t>5. Return Result</a:t>
+            </a:r>
+            <a:r>
+              <a:rPr lang="en-US" sz="1200"/>
+              <a:t/>
+            </a:r>
+            <a:r>
+              <a:rPr lang="en-US" sz="1200" dirty="0"/>
+              <a:t/>
+            </a:r>
+          </a:p>
+        </p:txBody>
+      </p:sp>
+      <p:cxnSp>
+        <p:nvCxnSpPr>
+          <p:cNvPr id="88" name="Straight Arrow Connector 87"/>
+          <p:cNvCxnSpPr/>
+          <p:nvPr/>
+        </p:nvCxnSpPr>
+        <p:spPr>
+          <a:xfrm rot="5400000">
+            <a:off x="7662580" y="2914941"/>
+            <a:ext cx="422144" cy="2533849"/>
+          </a:xfrm>
+          <a:prstGeom prst="bentConnector2">
+            <a:avLst/>
+          </a:prstGeom>
+          <a:ln>
+            <a:tailEnd type="triangle"/>
+          </a:ln>
+        </p:spPr>
+        <p:style>
+          <a:lnRef idx="2">
+            <a:schemeClr val="accent1"/>
+          </a:lnRef>
+          <a:fillRef idx="0">
+            <a:schemeClr val="accent1"/>
+          </a:fillRef>
+          <a:effectRef idx="1">
+            <a:schemeClr val="accent1"/>
+          </a:effectRef>
+          <a:fontRef idx="minor">
+            <a:schemeClr val="tx1"/>
+          </a:fontRef>
+        </p:style>
+      </p:cxnSp>
+      <p:sp>
+        <p:nvSpPr>
+          <p:cNvPr id="2" name="Can 1"/>
+          <p:cNvSpPr/>
+          <p:nvPr/>
+        </p:nvSpPr>
+        <p:spPr>
+          <a:xfrm>
+            <a:off x="11173710" y="3122264"/>
+            <a:ext cx="988828" cy="868444"/>
+          </a:xfrm>
+          <a:prstGeom prst="can">
+            <a:avLst/>
+          </a:prstGeom>
+          <a:solidFill>
+            <a:schemeClr val="bg1"/>
+          </a:solidFill>
+          <a:ln w="19050" cmpd="sng">
+            <a:solidFill>
+              <a:schemeClr val="tx1"/>
+            </a:solidFill>
+          </a:ln>
+        </p:spPr>
+        <p:style>
+          <a:lnRef idx="1">
+            <a:schemeClr val="accent1"/>
+          </a:lnRef>
+          <a:fillRef idx="3">
+            <a:schemeClr val="accent1"/>
+          </a:fillRef>
+          <a:effectRef idx="2">
+            <a:schemeClr val="accent1"/>
+          </a:effectRef>
+          <a:fontRef idx="minor">
+            <a:schemeClr val="lt1"/>
+          </a:fontRef>
+        </p:style>
+        <p:txBody>
+          <a:bodyPr lIns="91436" tIns="45718" rIns="91436" bIns="45718" rtlCol="0" anchor="ctr" anchorCtr="0"/>
+          <a:lstStyle/>
+          <a:p>
+            <a:pPr algn="ctr"/>
+            <a:r>
+              <a:rPr lang="en-US" sz="900" dirty="0">
+                <a:solidFill>
+                  <a:schemeClr val="tx1"/>
+                </a:solidFill>
+                <a:latin typeface="Helvetica"/>
+                <a:cs typeface="Helvetica"/>
+              </a:rPr>
+              <a:t>Recorded</a:t>
+            </a:r>
+          </a:p>
+          <a:p>
+            <a:pPr algn="ctr"/>
+            <a:r>
+              <a:rPr lang="en-US" sz="900" dirty="0">
+                <a:solidFill>
+                  <a:schemeClr val="tx1"/>
+                </a:solidFill>
+                <a:latin typeface="Helvetica"/>
+                <a:cs typeface="Helvetica"/>
+              </a:rPr>
+              <a:t>Responses</a:t>
+            </a:r>
+          </a:p>
+        </p:txBody>
+      </p:sp>
+      <p:sp>
+        <p:nvSpPr>
+          <p:cNvPr id="21" name="Rectangle 20"/>
+          <p:cNvSpPr/>
+          <p:nvPr/>
+        </p:nvSpPr>
+        <p:spPr>
+          <a:xfrm>
+            <a:off x="8664564" y="3242893"/>
+            <a:ext cx="940561" cy="664100"/>
+          </a:xfrm>
+          <a:prstGeom prst="rect">
+            <a:avLst/>
+          </a:prstGeom>
+          <a:solidFill>
+            <a:schemeClr val="bg1"/>
+          </a:solidFill>
+          <a:ln w="19050" cmpd="sng">
+            <a:solidFill>
+              <a:schemeClr val="tx1"/>
+            </a:solidFill>
+          </a:ln>
+        </p:spPr>
+        <p:style>
+          <a:lnRef idx="1">
+            <a:schemeClr val="accent1"/>
+          </a:lnRef>
+          <a:fillRef idx="3">
+            <a:schemeClr val="accent1"/>
+          </a:fillRef>
+          <a:effectRef idx="2">
+            <a:schemeClr val="accent1"/>
+          </a:effectRef>
+          <a:fontRef idx="minor">
+            <a:schemeClr val="lt1"/>
+          </a:fontRef>
+        </p:style>
+        <p:txBody>
+          <a:bodyPr lIns="91436" tIns="45718" rIns="91436" bIns="45718" rtlCol="0" anchor="ctr" anchorCtr="0"/>
+          <a:lstStyle/>
+          <a:p>
+            <a:pPr algn="ctr"/>
+            <a:r>
+              <a:rPr lang="en-US" sz="900" dirty="0">
+                <a:solidFill>
+                  <a:schemeClr val="tx1"/>
+                </a:solidFill>
+                <a:latin typeface="Helvetica"/>
+                <a:cs typeface="Helvetica"/>
+              </a:rPr>
+              <a:t>Request</a:t>
+            </a:r>
+          </a:p>
+          <a:p>
+            <a:pPr algn="ctr"/>
+            <a:r>
+              <a:rPr lang="en-US" sz="900" dirty="0">
+                <a:solidFill>
+                  <a:schemeClr val="tx1"/>
+                </a:solidFill>
+                <a:latin typeface="Helvetica"/>
+                <a:cs typeface="Helvetica"/>
+              </a:rPr>
+              <a:t>Matcher</a:t>
+            </a:r>
+          </a:p>
+        </p:txBody>
+      </p:sp>
+      <p:cxnSp>
+        <p:nvCxnSpPr>
+          <p:cNvPr id="7" name="Straight Arrow Connector 6"/>
+          <p:cNvCxnSpPr/>
+          <p:nvPr/>
+        </p:nvCxnSpPr>
+        <p:spPr>
+          <a:xfrm>
+            <a:off x="9714192" y="3567122"/>
+            <a:ext cx="1355774" cy="7823"/>
+          </a:xfrm>
+          <a:prstGeom prst="straightConnector1">
+            <a:avLst/>
+          </a:prstGeom>
+          <a:ln>
+            <a:headEnd type="triangle"/>
+            <a:tailEnd type="triangle"/>
+          </a:ln>
+        </p:spPr>
+        <p:style>
+          <a:lnRef idx="2">
+            <a:schemeClr val="accent1"/>
+          </a:lnRef>
+          <a:fillRef idx="0">
+            <a:schemeClr val="accent1"/>
+          </a:fillRef>
+          <a:effectRef idx="1">
+            <a:schemeClr val="accent1"/>
+          </a:effectRef>
+          <a:fontRef idx="minor">
+            <a:schemeClr val="tx1"/>
+          </a:fontRef>
+        </p:style>
+      </p:cxnSp>
+      <p:sp>
+        <p:nvSpPr>
+          <p:cNvPr id="28" name="TextBox 27"/>
+          <p:cNvSpPr txBox="1"/>
+          <p:nvPr/>
+        </p:nvSpPr>
+        <p:spPr>
+          <a:xfrm>
+            <a:off x="9639761" y="3274794"/>
+            <a:ext cx="1553402" cy="276999"/>
+          </a:xfrm>
+          <a:prstGeom prst="rect">
+            <a:avLst/>
+          </a:prstGeom>
+          <a:noFill/>
+        </p:spPr>
+        <p:txBody>
+          <a:bodyPr wrap="square" rtlCol="0">
+            <a:spAutoFit/>
+          </a:bodyPr>
+          <a:lstStyle/>
+          <a:p>
+            <a:r>
+              <a:rPr lang="en-US" sz="1200" dirty="0"/>
+              <a:t>4. Match Response(s)</a:t>
+            </a:r>
+          </a:p>
+        </p:txBody>
+      </p:sp>
+      <p:sp>
+        <p:nvSpPr>
+          <p:cNvPr id="31" name="Rounded Rectangle 30"/>
+          <p:cNvSpPr/>
+          <p:nvPr/>
+        </p:nvSpPr>
+        <p:spPr>
+          <a:xfrm>
+            <a:off x="8457229" y="1823774"/>
+            <a:ext cx="1355231" cy="1012102"/>
+          </a:xfrm>
+          <a:prstGeom prst="roundRect">
+            <a:avLst/>
+          </a:prstGeom>
+          <a:solidFill>
+            <a:schemeClr val="bg1"/>
+          </a:solidFill>
+          <a:ln w="19050" cmpd="sng">
+            <a:solidFill>
+              <a:schemeClr val="tx1">
+                <a:lumMod val="50000"/>
+                <a:lumOff val="50000"/>
+                <a:alpha val="70000"/>
+              </a:schemeClr>
+            </a:solidFill>
+            <a:prstDash val="dash"/>
+          </a:ln>
+        </p:spPr>
+        <p:style>
+          <a:lnRef idx="1">
+            <a:schemeClr val="accent1"/>
+          </a:lnRef>
+          <a:fillRef idx="3">
+            <a:schemeClr val="accent1"/>
+          </a:fillRef>
+          <a:effectRef idx="2">
+            <a:schemeClr val="accent1"/>
+          </a:effectRef>
+          <a:fontRef idx="minor">
+            <a:schemeClr val="lt1"/>
+          </a:fontRef>
+        </p:style>
+        <p:txBody>
+          <a:bodyPr rtlCol="0" anchor="ctr" anchorCtr="0"/>
+          <a:lstStyle/>
+          <a:p>
+            <a:pPr algn="ctr"/>
+            <a:r>
+              <a:rPr lang="en-US" sz="1200" dirty="0">
+                <a:solidFill>
+                  <a:schemeClr val="bg1">
+                    <a:lumMod val="50000"/>
+                  </a:schemeClr>
+                </a:solidFill>
+                <a:latin typeface="Helvetica"/>
+                <a:cs typeface="Helvetica"/>
+              </a:rPr>
+              <a:t>Expectation</a:t>
+            </a:r>
+          </a:p>
+          <a:p>
+            <a:pPr algn="ctr"/>
+            <a:r>
+              <a:rPr lang="en-US" sz="1200" dirty="0">
+                <a:solidFill>
+                  <a:schemeClr val="bg1">
+                    <a:lumMod val="50000"/>
+                  </a:schemeClr>
+                </a:solidFill>
+                <a:latin typeface="Helvetica"/>
+                <a:cs typeface="Helvetica"/>
+              </a:rPr>
+              <a:t>or</a:t>
+            </a:r>
+          </a:p>
+          <a:p>
+            <a:pPr algn="ctr"/>
+            <a:r>
+              <a:rPr lang="en-US" sz="1200" dirty="0">
+                <a:solidFill>
+                  <a:schemeClr val="bg1">
+                    <a:lumMod val="50000"/>
+                  </a:schemeClr>
+                </a:solidFill>
+                <a:latin typeface="Helvetica"/>
+                <a:cs typeface="Helvetica"/>
+              </a:rPr>
+              <a:t>Proxy</a:t>
+            </a:r>
+          </a:p>
+        </p:txBody>
+      </p:sp>
+      <p:cxnSp>
+        <p:nvCxnSpPr>
+          <p:cNvPr id="32" name="Straight Arrow Connector 31"/>
+          <p:cNvCxnSpPr/>
+          <p:nvPr/>
+        </p:nvCxnSpPr>
+        <p:spPr>
+          <a:xfrm flipV="1">
+            <a:off x="6606729" y="2326837"/>
+            <a:ext cx="1764891" cy="1888"/>
+          </a:xfrm>
+          <a:prstGeom prst="straightConnector1">
+            <a:avLst/>
+          </a:prstGeom>
+          <a:ln>
+            <a:solidFill>
+              <a:schemeClr val="accent1">
+                <a:alpha val="70000"/>
+              </a:schemeClr>
+            </a:solidFill>
+            <a:tailEnd type="arrow"/>
+          </a:ln>
+        </p:spPr>
+        <p:style>
+          <a:lnRef idx="2">
+            <a:schemeClr val="accent1"/>
+          </a:lnRef>
+          <a:fillRef idx="0">
+            <a:schemeClr val="accent1"/>
+          </a:fillRef>
+          <a:effectRef idx="1">
+            <a:schemeClr val="accent1"/>
+          </a:effectRef>
+          <a:fontRef idx="minor">
+            <a:schemeClr val="tx1"/>
+          </a:fontRef>
+        </p:style>
+      </p:cxnSp>
+      <p:sp>
+        <p:nvSpPr>
+          <p:cNvPr id="33" name="TextBox 32"/>
+          <p:cNvSpPr txBox="1"/>
+          <p:nvPr/>
+        </p:nvSpPr>
+        <p:spPr>
+          <a:xfrm>
+            <a:off x="6521665" y="2049840"/>
+            <a:ext cx="1715807" cy="276999"/>
+          </a:xfrm>
+          <a:prstGeom prst="rect">
+            <a:avLst/>
+          </a:prstGeom>
+          <a:noFill/>
+        </p:spPr>
+        <p:txBody>
+          <a:bodyPr wrap="square" rtlCol="0">
+            <a:spAutoFit/>
+          </a:bodyPr>
+          <a:lstStyle/>
+          <a:p>
+            <a:r>
+              <a:rPr lang="en-US" sz="1200" dirty="0">
+                <a:solidFill>
+                  <a:schemeClr val="bg1">
+                    <a:lumMod val="50000"/>
+                  </a:schemeClr>
+                </a:solidFill>
+              </a:rPr>
+              <a:t>1. Receive Request</a:t>
+            </a:r>
+          </a:p>
+        </p:txBody>
+      </p:sp>
+      <p:cxnSp>
+        <p:nvCxnSpPr>
+          <p:cNvPr id="22" name="Elbow Connector 21"/>
+          <p:cNvCxnSpPr/>
+          <p:nvPr/>
+        </p:nvCxnSpPr>
+        <p:spPr>
+          <a:xfrm>
+            <a:off x="9876256" y="2329825"/>
+            <a:ext cx="1783814" cy="741880"/>
+          </a:xfrm>
+          <a:prstGeom prst="bentConnector2">
+            <a:avLst/>
+          </a:prstGeom>
+          <a:ln>
+            <a:solidFill>
+              <a:schemeClr val="accent1">
+                <a:alpha val="70000"/>
+              </a:schemeClr>
+            </a:solidFill>
+            <a:tailEnd type="triangle"/>
+          </a:ln>
+        </p:spPr>
+        <p:style>
+          <a:lnRef idx="2">
+            <a:schemeClr val="accent1"/>
+          </a:lnRef>
+          <a:fillRef idx="0">
+            <a:schemeClr val="accent1"/>
+          </a:fillRef>
+          <a:effectRef idx="1">
+            <a:schemeClr val="accent1"/>
+          </a:effectRef>
+          <a:fontRef idx="minor">
+            <a:schemeClr val="tx1"/>
+          </a:fontRef>
+        </p:style>
+      </p:cxnSp>
+      <p:sp>
+        <p:nvSpPr>
+          <p:cNvPr id="38" name="TextBox 37"/>
+          <p:cNvSpPr txBox="1"/>
+          <p:nvPr/>
+        </p:nvSpPr>
+        <p:spPr>
+          <a:xfrm>
+            <a:off x="9812460" y="2060473"/>
+            <a:ext cx="1715807" cy="276999"/>
+          </a:xfrm>
+          <a:prstGeom prst="rect">
+            <a:avLst/>
+          </a:prstGeom>
+          <a:noFill/>
+        </p:spPr>
+        <p:txBody>
+          <a:bodyPr wrap="square" rtlCol="0">
+            <a:spAutoFit/>
+          </a:bodyPr>
+          <a:lstStyle/>
+          <a:p>
+            <a:r>
+              <a:rPr lang="en-US" sz="1200" dirty="0">
+                <a:solidFill>
+                  <a:schemeClr val="bg1">
+                    <a:lumMod val="50000"/>
+                  </a:schemeClr>
+                </a:solidFill>
+              </a:rPr>
+              <a:t>2. Record Response</a:t>
+            </a:r>
+          </a:p>
+        </p:txBody>
+      </p:sp>
+    </p:spTree>
+  </p:cSld>
+  <p:clrMapOvr>
+    <a:masterClrMapping/>
+  </p:clrMapOvr>
+</p:sld>
+</file>
+
+<file path=ppt/slides/slide15.xml><?xml version="1.0" encoding="utf-8"?>
+<p:sld xmlns:a="http://schemas.openxmlformats.org/drawingml/2006/main" xmlns:p="http://schemas.openxmlformats.org/presentationml/2006/main" xmlns:r="http://schemas.openxmlformats.org/officeDocument/2006/relationships">
+  <p:cSld>
+    <p:spTree>
+      <p:nvGrpSpPr>
+        <p:cNvPr id="1" name=""/>
+        <p:cNvGrpSpPr/>
+        <p:nvPr/>
+      </p:nvGrpSpPr>
+      <p:grpSpPr/>
+      <p:cxnSp>
+        <p:nvCxnSpPr>
+          <p:cNvPr id="17" name="Straight Arrow Connector 16"/>
+          <p:cNvCxnSpPr/>
+          <p:nvPr/>
+        </p:nvCxnSpPr>
+        <p:spPr>
+          <a:xfrm flipV="1">
+            <a:off x="6606727" y="3566175"/>
+            <a:ext cx="1983406" cy="4192"/>
+          </a:xfrm>
+          <a:prstGeom prst="straightConnector1">
+            <a:avLst/>
+          </a:prstGeom>
+          <a:ln>
+            <a:tailEnd type="arrow"/>
+          </a:ln>
+        </p:spPr>
+        <p:style>
+          <a:lnRef idx="2">
+            <a:schemeClr val="accent5"/>
+          </a:lnRef>
+          <a:fillRef idx="0">
+            <a:schemeClr val="accent5"/>
+          </a:fillRef>
+          <a:effectRef idx="1">
+            <a:schemeClr val="accent5"/>
+          </a:effectRef>
+          <a:fontRef idx="minor">
+            <a:schemeClr val="tx1"/>
+          </a:fontRef>
+        </p:style>
+      </p:cxnSp>
+      <p:sp>
+        <p:nvSpPr>
+          <p:cNvPr id="18" name="TextBox 17"/>
+          <p:cNvSpPr txBox="1"/>
+          <p:nvPr/>
+        </p:nvSpPr>
+        <p:spPr>
+          <a:xfrm>
+            <a:off x="6521663" y="3291482"/>
+            <a:ext cx="2759008" cy="276999"/>
+          </a:xfrm>
+          <a:prstGeom prst="rect">
+            <a:avLst/>
+          </a:prstGeom>
+          <a:noFill/>
+        </p:spPr>
+        <p:txBody>
+          <a:bodyPr wrap="square" rtlCol="0">
+            <a:spAutoFit/>
+          </a:bodyPr>
+          <a:lstStyle/>
+          <a:p>
+            <a:r>
+              <a:rPr lang="en-US" sz="1200" dirty="0"/>
+              <a:t>3. Request Brief</a:t>
+            </a:r>
+          </a:p>
+        </p:txBody>
+      </p:sp>
+      <p:sp>
+        <p:nvSpPr>
+          <p:cNvPr id="67" name="TextBox 66"/>
+          <p:cNvSpPr txBox="1"/>
+          <p:nvPr/>
+        </p:nvSpPr>
+        <p:spPr>
+          <a:xfrm>
+            <a:off x="6521663" y="4121697"/>
+            <a:ext cx="1553402" cy="276999"/>
+          </a:xfrm>
+          <a:prstGeom prst="rect">
+            <a:avLst/>
+          </a:prstGeom>
+          <a:noFill/>
+        </p:spPr>
+        <p:txBody>
+          <a:bodyPr wrap="square" rtlCol="0">
+            <a:spAutoFit/>
+          </a:bodyPr>
+          <a:lstStyle/>
+          <a:p>
+            <a:r>
+              <a:rPr lang="en-US" sz="1200" dirty="0"/>
+              <a:t>5. Export Brief</a:t>
+            </a:r>
+            <a:r>
+              <a:rPr lang="en-US" sz="1200"/>
+              <a:t/>
+            </a:r>
+            <a:r>
+              <a:rPr lang="en-US" sz="1200" dirty="0"/>
+              <a:t/>
+            </a:r>
+          </a:p>
+        </p:txBody>
+      </p:sp>
+      <p:cxnSp>
+        <p:nvCxnSpPr>
+          <p:cNvPr id="88" name="Straight Arrow Connector 87"/>
+          <p:cNvCxnSpPr/>
+          <p:nvPr/>
+        </p:nvCxnSpPr>
+        <p:spPr>
+          <a:xfrm rot="5400000">
+            <a:off x="7662580" y="2914941"/>
+            <a:ext cx="422144" cy="2533849"/>
+          </a:xfrm>
+          <a:prstGeom prst="bentConnector2">
+            <a:avLst/>
+          </a:prstGeom>
+          <a:ln>
+            <a:tailEnd type="triangle"/>
+          </a:ln>
+        </p:spPr>
+        <p:style>
+          <a:lnRef idx="2">
+            <a:schemeClr val="accent5"/>
+          </a:lnRef>
+          <a:fillRef idx="0">
+            <a:schemeClr val="accent5"/>
+          </a:fillRef>
+          <a:effectRef idx="1">
+            <a:schemeClr val="accent5"/>
+          </a:effectRef>
+          <a:fontRef idx="minor">
+            <a:schemeClr val="tx1"/>
+          </a:fontRef>
+        </p:style>
+      </p:cxnSp>
+      <p:sp>
+        <p:nvSpPr>
+          <p:cNvPr id="2" name="Can 1"/>
+          <p:cNvSpPr/>
+          <p:nvPr/>
+        </p:nvSpPr>
+        <p:spPr>
+          <a:xfrm>
+            <a:off x="11173710" y="3122264"/>
+            <a:ext cx="988828" cy="868444"/>
+          </a:xfrm>
+          <a:prstGeom prst="can">
+            <a:avLst/>
+          </a:prstGeom>
+          <a:solidFill>
+            <a:schemeClr val="bg1"/>
+          </a:solidFill>
+          <a:ln w="19050" cmpd="sng">
+            <a:solidFill>
+              <a:schemeClr val="tx1"/>
+            </a:solidFill>
+          </a:ln>
+        </p:spPr>
+        <p:style>
+          <a:lnRef idx="1">
+            <a:schemeClr val="accent5"/>
+          </a:lnRef>
+          <a:fillRef idx="3">
+            <a:schemeClr val="accent5"/>
+          </a:fillRef>
+          <a:effectRef idx="2">
+            <a:schemeClr val="accent5"/>
+          </a:effectRef>
+          <a:fontRef idx="minor">
+            <a:schemeClr val="lt1"/>
+          </a:fontRef>
+        </p:style>
+        <p:txBody>
+          <a:bodyPr lIns="91436" tIns="45718" rIns="91436" bIns="45718" rtlCol="0" anchor="ctr" anchorCtr="0"/>
+          <a:lstStyle/>
+          <a:p>
+            <a:pPr algn="ctr"/>
+            <a:r>
+              <a:rPr lang="en-US" sz="900" dirty="0">
+                <a:solidFill>
+                  <a:schemeClr val="tx1"/>
+                </a:solidFill>
+                <a:latin typeface="Helvetica"/>
+                <a:cs typeface="Helvetica"/>
+              </a:rPr>
+              <a:t>LLM</a:t>
+            </a:r>
+          </a:p>
+          <a:p>
+            <a:pPr algn="ctr"/>
+            <a:r>
+              <a:rPr lang="en-US" sz="900" dirty="0">
+                <a:solidFill>
+                  <a:schemeClr val="tx1"/>
+                </a:solidFill>
+                <a:latin typeface="Helvetica"/>
+                <a:cs typeface="Helvetica"/>
+              </a:rPr>
+              <a:t>Traffic</a:t>
+            </a:r>
+          </a:p>
+        </p:txBody>
+      </p:sp>
+      <p:sp>
+        <p:nvSpPr>
+          <p:cNvPr id="21" name="Rectangle 20"/>
+          <p:cNvSpPr/>
+          <p:nvPr/>
+        </p:nvSpPr>
+        <p:spPr>
+          <a:xfrm>
+            <a:off x="8664564" y="3242893"/>
+            <a:ext cx="940561" cy="664100"/>
+          </a:xfrm>
+          <a:prstGeom prst="rect">
+            <a:avLst/>
+          </a:prstGeom>
+          <a:solidFill>
+            <a:schemeClr val="bg1"/>
+          </a:solidFill>
+          <a:ln w="19050" cmpd="sng">
+            <a:solidFill>
+              <a:schemeClr val="tx1"/>
+            </a:solidFill>
+          </a:ln>
+        </p:spPr>
+        <p:style>
+          <a:lnRef idx="1">
+            <a:schemeClr val="accent5"/>
+          </a:lnRef>
+          <a:fillRef idx="3">
+            <a:schemeClr val="accent5"/>
+          </a:fillRef>
+          <a:effectRef idx="2">
+            <a:schemeClr val="accent5"/>
+          </a:effectRef>
+          <a:fontRef idx="minor">
+            <a:schemeClr val="lt1"/>
+          </a:fontRef>
+        </p:style>
+        <p:txBody>
+          <a:bodyPr lIns="91436" tIns="45718" rIns="91436" bIns="45718" rtlCol="0" anchor="ctr" anchorCtr="0"/>
+          <a:lstStyle/>
+          <a:p>
+            <a:pPr algn="ctr"/>
+            <a:r>
+              <a:rPr lang="en-US" sz="900" dirty="0">
+                <a:solidFill>
+                  <a:schemeClr val="tx1"/>
+                </a:solidFill>
+                <a:latin typeface="Helvetica"/>
+                <a:cs typeface="Helvetica"/>
+              </a:rPr>
+              <a:t>Request</a:t>
+            </a:r>
+          </a:p>
+          <a:p>
+            <a:pPr algn="ctr"/>
+            <a:r>
+              <a:rPr lang="en-US" sz="900" dirty="0">
+                <a:solidFill>
+                  <a:schemeClr val="tx1"/>
+                </a:solidFill>
+                <a:latin typeface="Helvetica"/>
+                <a:cs typeface="Helvetica"/>
+              </a:rPr>
+              <a:t>Matcher</a:t>
+            </a:r>
+          </a:p>
+        </p:txBody>
+      </p:sp>
+      <p:cxnSp>
+        <p:nvCxnSpPr>
+          <p:cNvPr id="7" name="Straight Arrow Connector 6"/>
+          <p:cNvCxnSpPr/>
+          <p:nvPr/>
+        </p:nvCxnSpPr>
+        <p:spPr>
+          <a:xfrm>
+            <a:off x="9714192" y="3567122"/>
+            <a:ext cx="1355774" cy="7823"/>
+          </a:xfrm>
+          <a:prstGeom prst="straightConnector1">
+            <a:avLst/>
+          </a:prstGeom>
+          <a:ln>
+            <a:headEnd type="triangle"/>
+            <a:tailEnd type="triangle"/>
+          </a:ln>
+        </p:spPr>
+        <p:style>
+          <a:lnRef idx="2">
+            <a:schemeClr val="accent5"/>
+          </a:lnRef>
+          <a:fillRef idx="0">
+            <a:schemeClr val="accent5"/>
+          </a:fillRef>
+          <a:effectRef idx="1">
+            <a:schemeClr val="accent5"/>
+          </a:effectRef>
+          <a:fontRef idx="minor">
+            <a:schemeClr val="tx1"/>
+          </a:fontRef>
+        </p:style>
+      </p:cxnSp>
+      <p:sp>
+        <p:nvSpPr>
+          <p:cNvPr id="28" name="TextBox 27"/>
+          <p:cNvSpPr txBox="1"/>
+          <p:nvPr/>
+        </p:nvSpPr>
+        <p:spPr>
+          <a:xfrm>
+            <a:off x="9639761" y="3274794"/>
+            <a:ext cx="1553402" cy="276999"/>
+          </a:xfrm>
+          <a:prstGeom prst="rect">
+            <a:avLst/>
+          </a:prstGeom>
+          <a:noFill/>
+        </p:spPr>
+        <p:txBody>
+          <a:bodyPr wrap="square" rtlCol="0">
+            <a:spAutoFit/>
+          </a:bodyPr>
+          <a:lstStyle/>
+          <a:p>
+            <a:r>
+              <a:rPr lang="en-US" sz="1200" dirty="0"/>
+              <a:t>4. Analyse Traffic</a:t>
+            </a:r>
+          </a:p>
+        </p:txBody>
+      </p:sp>
+      <p:sp>
+        <p:nvSpPr>
+          <p:cNvPr id="31" name="Rounded Rectangle 30"/>
+          <p:cNvSpPr/>
+          <p:nvPr/>
+        </p:nvSpPr>
+        <p:spPr>
+          <a:xfrm>
+            <a:off x="8457229" y="1823774"/>
+            <a:ext cx="1355231" cy="1012102"/>
+          </a:xfrm>
+          <a:prstGeom prst="roundRect">
+            <a:avLst/>
+          </a:prstGeom>
+          <a:solidFill>
+            <a:schemeClr val="bg1"/>
+          </a:solidFill>
+          <a:ln w="19050" cmpd="sng">
+            <a:solidFill>
+              <a:schemeClr val="tx1">
+                <a:lumMod val="50000"/>
+                <a:lumOff val="50000"/>
+                <a:alpha val="70000"/>
+              </a:schemeClr>
+            </a:solidFill>
+            <a:prstDash val="dash"/>
+          </a:ln>
+        </p:spPr>
+        <p:style>
+          <a:lnRef idx="1">
+            <a:schemeClr val="accent5"/>
+          </a:lnRef>
+          <a:fillRef idx="3">
+            <a:schemeClr val="accent5"/>
+          </a:fillRef>
+          <a:effectRef idx="2">
+            <a:schemeClr val="accent5"/>
+          </a:effectRef>
+          <a:fontRef idx="minor">
+            <a:schemeClr val="lt1"/>
+          </a:fontRef>
+        </p:style>
+        <p:txBody>
+          <a:bodyPr rtlCol="0" anchor="ctr" anchorCtr="0"/>
+          <a:lstStyle/>
+          <a:p>
+            <a:pPr algn="ctr"/>
+            <a:r>
+              <a:rPr lang="en-US" sz="1200" dirty="0">
+                <a:solidFill>
+                  <a:schemeClr val="bg1">
+                    <a:lumMod val="50000"/>
+                  </a:schemeClr>
+                </a:solidFill>
+                <a:latin typeface="Helvetica"/>
+                <a:cs typeface="Helvetica"/>
+              </a:rPr>
+              <a:t>Proxy</a:t>
+            </a:r>
+          </a:p>
+        </p:txBody>
+      </p:sp>
+      <p:cxnSp>
+        <p:nvCxnSpPr>
+          <p:cNvPr id="32" name="Straight Arrow Connector 31"/>
+          <p:cNvCxnSpPr/>
+          <p:nvPr/>
+        </p:nvCxnSpPr>
+        <p:spPr>
+          <a:xfrm flipV="1">
+            <a:off x="6606729" y="2326837"/>
+            <a:ext cx="1764891" cy="1888"/>
+          </a:xfrm>
+          <a:prstGeom prst="straightConnector1">
+            <a:avLst/>
+          </a:prstGeom>
+          <a:ln>
+            <a:solidFill>
+              <a:schemeClr val="accent5">
+                <a:alpha val="70000"/>
+              </a:schemeClr>
+            </a:solidFill>
+            <a:tailEnd type="arrow"/>
+          </a:ln>
+        </p:spPr>
+        <p:style>
+          <a:lnRef idx="2">
+            <a:schemeClr val="accent5"/>
+          </a:lnRef>
+          <a:fillRef idx="0">
+            <a:schemeClr val="accent5"/>
+          </a:fillRef>
+          <a:effectRef idx="1">
+            <a:schemeClr val="accent5"/>
+          </a:effectRef>
+          <a:fontRef idx="minor">
+            <a:schemeClr val="tx1"/>
+          </a:fontRef>
+        </p:style>
+      </p:cxnSp>
+      <p:sp>
+        <p:nvSpPr>
+          <p:cNvPr id="33" name="TextBox 32"/>
+          <p:cNvSpPr txBox="1"/>
+          <p:nvPr/>
+        </p:nvSpPr>
+        <p:spPr>
+          <a:xfrm>
+            <a:off x="6521665" y="2049840"/>
+            <a:ext cx="1715807" cy="276999"/>
+          </a:xfrm>
+          <a:prstGeom prst="rect">
+            <a:avLst/>
+          </a:prstGeom>
+          <a:noFill/>
+        </p:spPr>
+        <p:txBody>
+          <a:bodyPr wrap="square" rtlCol="0">
+            <a:spAutoFit/>
+          </a:bodyPr>
+          <a:lstStyle/>
+          <a:p>
+            <a:r>
+              <a:rPr lang="en-US" sz="1200" dirty="0">
+                <a:solidFill>
+                  <a:schemeClr val="bg1">
+                    <a:lumMod val="50000"/>
+                  </a:schemeClr>
+                </a:solidFill>
+              </a:rPr>
+              <a:t>1. Proxy LLM Call</a:t>
+            </a:r>
+          </a:p>
+        </p:txBody>
+      </p:sp>
+      <p:cxnSp>
+        <p:nvCxnSpPr>
+          <p:cNvPr id="22" name="Elbow Connector 21"/>
+          <p:cNvCxnSpPr/>
+          <p:nvPr/>
+        </p:nvCxnSpPr>
+        <p:spPr>
+          <a:xfrm>
+            <a:off x="9876256" y="2329825"/>
+            <a:ext cx="1783814" cy="741880"/>
+          </a:xfrm>
+          <a:prstGeom prst="bentConnector2">
+            <a:avLst/>
+          </a:prstGeom>
+          <a:ln>
+            <a:solidFill>
+              <a:schemeClr val="accent5">
+                <a:alpha val="70000"/>
+              </a:schemeClr>
+            </a:solidFill>
+            <a:tailEnd type="triangle"/>
+          </a:ln>
+        </p:spPr>
+        <p:style>
+          <a:lnRef idx="2">
+            <a:schemeClr val="accent5"/>
+          </a:lnRef>
+          <a:fillRef idx="0">
+            <a:schemeClr val="accent5"/>
+          </a:fillRef>
+          <a:effectRef idx="1">
+            <a:schemeClr val="accent5"/>
+          </a:effectRef>
+          <a:fontRef idx="minor">
+            <a:schemeClr val="tx1"/>
+          </a:fontRef>
+        </p:style>
+      </p:cxnSp>
+      <p:sp>
+        <p:nvSpPr>
+          <p:cNvPr id="38" name="TextBox 37"/>
+          <p:cNvSpPr txBox="1"/>
+          <p:nvPr/>
+        </p:nvSpPr>
+        <p:spPr>
+          <a:xfrm>
+            <a:off x="9812460" y="2060473"/>
+            <a:ext cx="1715807" cy="276999"/>
+          </a:xfrm>
+          <a:prstGeom prst="rect">
+            <a:avLst/>
+          </a:prstGeom>
+          <a:noFill/>
+        </p:spPr>
+        <p:txBody>
+          <a:bodyPr wrap="square" rtlCol="0">
+            <a:spAutoFit/>
+          </a:bodyPr>
+          <a:lstStyle/>
+          <a:p>
+            <a:r>
+              <a:rPr lang="en-US" sz="1200" dirty="0">
+                <a:solidFill>
+                  <a:schemeClr val="bg1">
+                    <a:lumMod val="50000"/>
+                  </a:schemeClr>
+                </a:solidFill>
+              </a:rPr>
+              <a:t>2. Record Traffic</a:t>
+            </a:r>
+          </a:p>
+        </p:txBody>
+      </p:sp>
+    </p:spTree>
+  </p:cSld>
+  <p:clrMapOvr>
+    <a:masterClrMapping/>
+  </p:clrMapOvr>
+</p:sld>
+</file>
+
 <file path=ppt/slides/slide2.xml><?xml version="1.0" encoding="utf-8"?>
 <p:sld xmlns:a="http://schemas.openxmlformats.org/drawingml/2006/main" xmlns:r="http://schemas.openxmlformats.org/officeDocument/2006/relationships" xmlns:p="http://schemas.openxmlformats.org/presentationml/2006/main">
   <p:cSld>

</xml_diff>